<commit_message>
Decks: bigger database diagrams, no open-work slide; Excalidraw diagrams
docs/diagrams/xchannel.excalidraw holds the architecture, the database and the main
flows as editable shapes (open it at excalidraw.com).
</commit_message>
<xml_diff>
--- a/docs/XChannel-presentasi.pptx
+++ b/docs/XChannel-presentasi.pptx
@@ -19,10 +19,9 @@
     <p:sldId id="267" r:id="rId13"/>
     <p:sldId id="268" r:id="rId14"/>
     <p:sldId id="269" r:id="rId15"/>
-    <p:sldId id="270" r:id="rId16"/>
   </p:sldIdLst>
   <p:notesMasterIdLst>
-    <p:notesMasterId r:id="rId17"/>
+    <p:notesMasterId r:id="rId16"/>
   </p:notesMasterIdLst>
   <p:sldSz cx="12192000" cy="6858000"/>
   <p:notesSz cx="6858000" cy="12192000"/>
@@ -121,18 +120,18 @@
   <p:extLst>
     <p:ext uri="{521415D9-36F7-43E2-AB2F-B90AF26B5E84}">
       <p14:sectionLst xmlns:p14="http://schemas.microsoft.com/office/powerpoint/2010/main">
-        <p14:section name="Pembuka" id="{6cafd7c0-2ae9-c666-3e63-7ac703ff02eb}">
+        <p14:section name="Pembuka" id="{57f15e5b-4e25-1780-ca25-f04dde00cc71}">
           <p14:sldIdLst>
             <p14:sldId id="256"/>
           </p14:sldIdLst>
         </p14:section>
-        <p14:section name="Produk" id="{1ff58dc5-413c-bcf6-ea6d-b9cd3a5715a1}">
+        <p14:section name="Produk" id="{20ff58c5-5f3f-6c42-99aa-6822d8457d33}">
           <p14:sldIdLst>
             <p14:sldId id="257"/>
             <p14:sldId id="258"/>
           </p14:sldIdLst>
         </p14:section>
-        <p14:section name="Desain sistem" id="{71e5f6f1-df7e-4e66-337a-7ce6b7d9f201}">
+        <p14:section name="Desain sistem" id="{dc0b9696-427c-282b-39d0-2f1a9f985f0e}">
           <p14:sldIdLst>
             <p14:sldId id="259"/>
             <p14:sldId id="260"/>
@@ -140,24 +139,23 @@
             <p14:sldId id="262"/>
           </p14:sldIdLst>
         </p14:section>
-        <p14:section name="Aturan jadwal" id="{bab7dc17-79fd-9c47-153f-1e7cc8369ef3}">
+        <p14:section name="Aturan jadwal" id="{df5e34f7-03a1-80fa-3a70-ca445a3ea74b}">
           <p14:sldIdLst>
             <p14:sldId id="263"/>
             <p14:sldId id="264"/>
             <p14:sldId id="265"/>
           </p14:sldIdLst>
         </p14:section>
-        <p14:section name="Kode" id="{e222315c-0483-3914-ed18-24b8d6bfd231}">
+        <p14:section name="Kode" id="{3f5af054-1308-b693-7522-1dfdef726cb2}">
           <p14:sldIdLst>
             <p14:sldId id="266"/>
             <p14:sldId id="267"/>
             <p14:sldId id="268"/>
           </p14:sldIdLst>
         </p14:section>
-        <p14:section name="Penutup" id="{c4f380d6-e3b0-5679-668e-c46f138db6ba}">
+        <p14:section name="Penutup" id="{5213f0a3-4312-7575-17dd-f2767758e922}">
           <p14:sldIdLst>
             <p14:sldId id="269"/>
-            <p14:sldId id="270"/>
           </p14:sldIdLst>
         </p14:section>
       </p14:sectionLst>
@@ -1004,7 +1002,7 @@
           <a:p>
             <a:r>
               <a:rPr lang="en-US" dirty="0"/>
-              <a:t>Menyebutkan yang belum selesai sendiri menunjukkan saya tahu di mana sistemnya tipis. Pilih satu untuk dibahas.</a:t>
+              <a:t>Tutup dengan link. Tawarkan untuk membuka demo atau kode di layar.</a:t>
             </a:r>
             <a:endParaRPr lang="en-US" dirty="0"/>
           </a:p>
@@ -1028,94 +1026,6 @@
             <a:fld id="{F7021451-1387-4CA6-816F-3879F97B5CBC}" type="slidenum">
               <a:rPr lang="en-US"/>
               <a:t>14</a:t>
-            </a:fld>
-            <a:endParaRPr lang="en-US"/>
-          </a:p>
-        </p:txBody>
-      </p:sp>
-    </p:spTree>
-    <p:extLst>
-      <p:ext uri="{BB962C8B-B14F-4D97-AF65-F5344CB8AC3E}">
-        <p14:creationId xmlns:p14="http://schemas.microsoft.com/office/powerpoint/2010/main" val="1024086991"/>
-      </p:ext>
-    </p:extLst>
-  </p:cSld>
-  <p:clrMapOvr>
-    <a:masterClrMapping/>
-  </p:clrMapOvr>
-</p:notes>
-</file>
-
-<file path=ppt/notesSlides/notesSlide15.xml><?xml version="1.0" encoding="utf-8"?>
-<p:notes xmlns:a="http://schemas.openxmlformats.org/drawingml/2006/main" xmlns:r="http://schemas.openxmlformats.org/officeDocument/2006/relationships" xmlns:p="http://schemas.openxmlformats.org/presentationml/2006/main">
-  <p:cSld>
-    <p:spTree>
-      <p:nvGrpSpPr>
-        <p:cNvPr id="1" name=""/>
-        <p:cNvGrpSpPr/>
-        <p:nvPr/>
-      </p:nvGrpSpPr>
-      <p:grpSpPr>
-        <a:xfrm>
-          <a:off x="0" y="0"/>
-          <a:ext cx="0" cy="0"/>
-          <a:chOff x="0" y="0"/>
-          <a:chExt cx="0" cy="0"/>
-        </a:xfrm>
-      </p:grpSpPr>
-      <p:sp>
-        <p:nvSpPr>
-          <p:cNvPr id="2" name="Slide Image Placeholder 1"/>
-          <p:cNvSpPr>
-            <a:spLocks noGrp="1" noRot="1" noChangeAspect="1"/>
-          </p:cNvSpPr>
-          <p:nvPr>
-            <p:ph type="sldImg"/>
-          </p:nvPr>
-        </p:nvSpPr>
-        <p:spPr/>
-      </p:sp>
-      <p:sp>
-        <p:nvSpPr>
-          <p:cNvPr id="3" name="Notes Placeholder 2"/>
-          <p:cNvSpPr>
-            <a:spLocks noGrp="1"/>
-          </p:cNvSpPr>
-          <p:nvPr>
-            <p:ph type="body" idx="1"/>
-          </p:nvPr>
-        </p:nvSpPr>
-        <p:spPr/>
-        <p:txBody>
-          <a:bodyPr/>
-          <a:lstStyle/>
-          <a:p>
-            <a:r>
-              <a:rPr lang="en-US" dirty="0"/>
-              <a:t>Tutup dengan link. Tawarkan untuk membuka demo atau kode di layar.</a:t>
-            </a:r>
-            <a:endParaRPr lang="en-US" dirty="0"/>
-          </a:p>
-        </p:txBody>
-      </p:sp>
-      <p:sp>
-        <p:nvSpPr>
-          <p:cNvPr id="4" name="Slide Number Placeholder 3"/>
-          <p:cNvSpPr>
-            <a:spLocks noGrp="1"/>
-          </p:cNvSpPr>
-          <p:nvPr>
-            <p:ph type="sldNum" sz="quarter" idx="10"/>
-          </p:nvPr>
-        </p:nvSpPr>
-        <p:spPr/>
-        <p:txBody>
-          <a:bodyPr/>
-          <a:lstStyle/>
-          <a:p>
-            <a:fld id="{F7021451-1387-4CA6-816F-3879F97B5CBC}" type="slidenum">
-              <a:rPr lang="en-US"/>
-              <a:t>15</a:t>
             </a:fld>
             <a:endParaRPr lang="en-US"/>
           </a:p>
@@ -5172,740 +5082,6 @@
                   <a:schemeClr val="bg1"/>
                 </a:solidFill>
               </a:rPr>
-              <a:t>Yang belum selesai</a:t>
-            </a:r>
-            <a:endParaRPr lang="en-US" sz="3200" dirty="0"/>
-          </a:p>
-        </p:txBody>
-      </p:sp>
-      <p:graphicFrame>
-        <p:nvGraphicFramePr>
-          <p:cNvPr id="15" name="Table 0"/>
-          <p:cNvGraphicFramePr>
-            <a:graphicFrameLocks noGrp="1"/>
-          </p:cNvGraphicFramePr>
-          <p:nvPr>
-            <p:extLst>
-              <p:ext uri="{D42A27DB-BD31-4B8C-83A1-F6EECF244321}">
-                <p14:modId xmlns:p14="http://schemas.microsoft.com/office/powerpoint/2010/main" val="1579011935"/>
-              </p:ext>
-            </p:extLst>
-          </p:nvPr>
-        </p:nvGraphicFramePr>
-        <p:xfrm>
-          <a:off x="548640" y="1463040"/>
-          <a:ext cx="11064240" cy="914400"/>
-        </p:xfrm>
-        <a:graphic>
-          <a:graphicData uri="http://schemas.openxmlformats.org/drawingml/2006/table">
-            <a:tbl>
-              <a:tblPr/>
-              <a:tblGrid>
-                <a:gridCol w="4023360"/>
-                <a:gridCol w="7040880"/>
-              </a:tblGrid>
-              <a:tr h="0">
-                <a:tc>
-                  <a:txBody>
-                    <a:bodyPr/>
-                    <a:lstStyle/>
-                    <a:p>
-                      <a:pPr indent="0" marL="0">
-                        <a:buNone/>
-                      </a:pPr>
-                      <a:r>
-                        <a:rPr lang="en-US" sz="1500" b="1" dirty="0">
-                          <a:solidFill>
-                            <a:srgbClr val="E0313E"/>
-                          </a:solidFill>
-                        </a:rPr>
-                        <a:t>Yang belum</a:t>
-                      </a:r>
-                      <a:endParaRPr lang="en-US" sz="1500" dirty="0"/>
-                    </a:p>
-                  </a:txBody>
-                  <a:tcPr marL="164592" marR="164592" marT="182880" marB="182880" anchor="t">
-                    <a:lnL w="9525" cap="flat" cmpd="sng" algn="ctr">
-                      <a:solidFill>
-                        <a:srgbClr val="3A3D46"/>
-                      </a:solidFill>
-                      <a:prstDash val="solid"/>
-                      <a:round/>
-                      <a:headEnd type="none" w="med" len="med"/>
-                      <a:tailEnd type="none" w="med" len="med"/>
-                    </a:lnL>
-                    <a:lnR w="9525" cap="flat" cmpd="sng" algn="ctr">
-                      <a:solidFill>
-                        <a:srgbClr val="3A3D46"/>
-                      </a:solidFill>
-                      <a:prstDash val="solid"/>
-                      <a:round/>
-                      <a:headEnd type="none" w="med" len="med"/>
-                      <a:tailEnd type="none" w="med" len="med"/>
-                    </a:lnR>
-                    <a:lnT w="9525" cap="flat" cmpd="sng" algn="ctr">
-                      <a:solidFill>
-                        <a:srgbClr val="3A3D46"/>
-                      </a:solidFill>
-                      <a:prstDash val="solid"/>
-                      <a:round/>
-                      <a:headEnd type="none" w="med" len="med"/>
-                      <a:tailEnd type="none" w="med" len="med"/>
-                    </a:lnT>
-                    <a:lnB w="9525" cap="flat" cmpd="sng" algn="ctr">
-                      <a:solidFill>
-                        <a:srgbClr val="3A3D46"/>
-                      </a:solidFill>
-                      <a:prstDash val="solid"/>
-                      <a:round/>
-                      <a:headEnd type="none" w="med" len="med"/>
-                      <a:tailEnd type="none" w="med" len="med"/>
-                    </a:lnB>
-                    <a:solidFill>
-                      <a:srgbClr val="25272E"/>
-                    </a:solidFill>
-                  </a:tcPr>
-                </a:tc>
-                <a:tc>
-                  <a:txBody>
-                    <a:bodyPr/>
-                    <a:lstStyle/>
-                    <a:p>
-                      <a:pPr indent="0" marL="0">
-                        <a:buNone/>
-                      </a:pPr>
-                      <a:r>
-                        <a:rPr lang="en-US" sz="1500" b="1" dirty="0">
-                          <a:solidFill>
-                            <a:srgbClr val="E0313E"/>
-                          </a:solidFill>
-                        </a:rPr>
-                        <a:t>Langkah pertama</a:t>
-                      </a:r>
-                      <a:endParaRPr lang="en-US" sz="1500" dirty="0"/>
-                    </a:p>
-                  </a:txBody>
-                  <a:tcPr marL="164592" marR="164592" marT="182880" marB="182880" anchor="t">
-                    <a:lnL w="9525" cap="flat" cmpd="sng" algn="ctr">
-                      <a:solidFill>
-                        <a:srgbClr val="3A3D46"/>
-                      </a:solidFill>
-                      <a:prstDash val="solid"/>
-                      <a:round/>
-                      <a:headEnd type="none" w="med" len="med"/>
-                      <a:tailEnd type="none" w="med" len="med"/>
-                    </a:lnL>
-                    <a:lnR w="9525" cap="flat" cmpd="sng" algn="ctr">
-                      <a:solidFill>
-                        <a:srgbClr val="3A3D46"/>
-                      </a:solidFill>
-                      <a:prstDash val="solid"/>
-                      <a:round/>
-                      <a:headEnd type="none" w="med" len="med"/>
-                      <a:tailEnd type="none" w="med" len="med"/>
-                    </a:lnR>
-                    <a:lnT w="9525" cap="flat" cmpd="sng" algn="ctr">
-                      <a:solidFill>
-                        <a:srgbClr val="3A3D46"/>
-                      </a:solidFill>
-                      <a:prstDash val="solid"/>
-                      <a:round/>
-                      <a:headEnd type="none" w="med" len="med"/>
-                      <a:tailEnd type="none" w="med" len="med"/>
-                    </a:lnT>
-                    <a:lnB w="9525" cap="flat" cmpd="sng" algn="ctr">
-                      <a:solidFill>
-                        <a:srgbClr val="3A3D46"/>
-                      </a:solidFill>
-                      <a:prstDash val="solid"/>
-                      <a:round/>
-                      <a:headEnd type="none" w="med" len="med"/>
-                      <a:tailEnd type="none" w="med" len="med"/>
-                    </a:lnB>
-                    <a:solidFill>
-                      <a:srgbClr val="25272E"/>
-                    </a:solidFill>
-                  </a:tcPr>
-                </a:tc>
-              </a:tr>
-              <a:tr h="0">
-                <a:tc>
-                  <a:txBody>
-                    <a:bodyPr/>
-                    <a:lstStyle/>
-                    <a:p>
-                      <a:pPr indent="0" marL="0">
-                        <a:buNone/>
-                      </a:pPr>
-                      <a:r>
-                        <a:rPr lang="en-US" sz="1700" b="1" dirty="0">
-                          <a:solidFill>
-                            <a:srgbClr val="FFFFFF"/>
-                          </a:solidFill>
-                        </a:rPr>
-                        <a:t>Produksi masih satu tabel per kota</a:t>
-                      </a:r>
-                      <a:endParaRPr lang="en-US" sz="1700" dirty="0"/>
-                    </a:p>
-                  </a:txBody>
-                  <a:tcPr marL="164592" marR="164592" marT="182880" marB="182880" anchor="t">
-                    <a:lnL w="9525" cap="flat" cmpd="sng" algn="ctr">
-                      <a:solidFill>
-                        <a:srgbClr val="3A3D46"/>
-                      </a:solidFill>
-                      <a:prstDash val="solid"/>
-                      <a:round/>
-                      <a:headEnd type="none" w="med" len="med"/>
-                      <a:tailEnd type="none" w="med" len="med"/>
-                    </a:lnL>
-                    <a:lnR w="9525" cap="flat" cmpd="sng" algn="ctr">
-                      <a:solidFill>
-                        <a:srgbClr val="3A3D46"/>
-                      </a:solidFill>
-                      <a:prstDash val="solid"/>
-                      <a:round/>
-                      <a:headEnd type="none" w="med" len="med"/>
-                      <a:tailEnd type="none" w="med" len="med"/>
-                    </a:lnR>
-                    <a:lnT w="9525" cap="flat" cmpd="sng" algn="ctr">
-                      <a:solidFill>
-                        <a:srgbClr val="3A3D46"/>
-                      </a:solidFill>
-                      <a:prstDash val="solid"/>
-                      <a:round/>
-                      <a:headEnd type="none" w="med" len="med"/>
-                      <a:tailEnd type="none" w="med" len="med"/>
-                    </a:lnT>
-                    <a:lnB w="9525" cap="flat" cmpd="sng" algn="ctr">
-                      <a:solidFill>
-                        <a:srgbClr val="3A3D46"/>
-                      </a:solidFill>
-                      <a:prstDash val="solid"/>
-                      <a:round/>
-                      <a:headEnd type="none" w="med" len="med"/>
-                      <a:tailEnd type="none" w="med" len="med"/>
-                    </a:lnB>
-                  </a:tcPr>
-                </a:tc>
-                <a:tc>
-                  <a:txBody>
-                    <a:bodyPr/>
-                    <a:lstStyle/>
-                    <a:p>
-                      <a:pPr indent="0" marL="0">
-                        <a:buNone/>
-                      </a:pPr>
-                      <a:r>
-                        <a:rPr lang="en-US" sz="1700" dirty="0">
-                          <a:solidFill>
-                            <a:srgbClr val="AEB2BC"/>
-                          </a:solidFill>
-                        </a:rPr>
-                        <a:t>Isi schedule_slots dari tabel lama, buat view per kota untuk API lama, lalu pindahkan pembaca bertahap</a:t>
-                      </a:r>
-                      <a:endParaRPr lang="en-US" sz="1700" dirty="0"/>
-                    </a:p>
-                  </a:txBody>
-                  <a:tcPr marL="164592" marR="164592" marT="182880" marB="182880" anchor="t">
-                    <a:lnL w="9525" cap="flat" cmpd="sng" algn="ctr">
-                      <a:solidFill>
-                        <a:srgbClr val="3A3D46"/>
-                      </a:solidFill>
-                      <a:prstDash val="solid"/>
-                      <a:round/>
-                      <a:headEnd type="none" w="med" len="med"/>
-                      <a:tailEnd type="none" w="med" len="med"/>
-                    </a:lnL>
-                    <a:lnR w="9525" cap="flat" cmpd="sng" algn="ctr">
-                      <a:solidFill>
-                        <a:srgbClr val="3A3D46"/>
-                      </a:solidFill>
-                      <a:prstDash val="solid"/>
-                      <a:round/>
-                      <a:headEnd type="none" w="med" len="med"/>
-                      <a:tailEnd type="none" w="med" len="med"/>
-                    </a:lnR>
-                    <a:lnT w="9525" cap="flat" cmpd="sng" algn="ctr">
-                      <a:solidFill>
-                        <a:srgbClr val="3A3D46"/>
-                      </a:solidFill>
-                      <a:prstDash val="solid"/>
-                      <a:round/>
-                      <a:headEnd type="none" w="med" len="med"/>
-                      <a:tailEnd type="none" w="med" len="med"/>
-                    </a:lnT>
-                    <a:lnB w="9525" cap="flat" cmpd="sng" algn="ctr">
-                      <a:solidFill>
-                        <a:srgbClr val="3A3D46"/>
-                      </a:solidFill>
-                      <a:prstDash val="solid"/>
-                      <a:round/>
-                      <a:headEnd type="none" w="med" len="med"/>
-                      <a:tailEnd type="none" w="med" len="med"/>
-                    </a:lnB>
-                  </a:tcPr>
-                </a:tc>
-              </a:tr>
-              <a:tr h="0">
-                <a:tc>
-                  <a:txBody>
-                    <a:bodyPr/>
-                    <a:lstStyle/>
-                    <a:p>
-                      <a:pPr indent="0" marL="0">
-                        <a:buNone/>
-                      </a:pPr>
-                      <a:r>
-                        <a:rPr lang="en-US" sz="1700" b="1" dirty="0">
-                          <a:solidFill>
-                            <a:srgbClr val="FFFFFF"/>
-                          </a:solidFill>
-                        </a:rPr>
-                        <a:t>Semua jam dianggap WIB</a:t>
-                      </a:r>
-                      <a:endParaRPr lang="en-US" sz="1700" dirty="0"/>
-                    </a:p>
-                  </a:txBody>
-                  <a:tcPr marL="164592" marR="164592" marT="182880" marB="182880" anchor="t">
-                    <a:lnL w="9525" cap="flat" cmpd="sng" algn="ctr">
-                      <a:solidFill>
-                        <a:srgbClr val="3A3D46"/>
-                      </a:solidFill>
-                      <a:prstDash val="solid"/>
-                      <a:round/>
-                      <a:headEnd type="none" w="med" len="med"/>
-                      <a:tailEnd type="none" w="med" len="med"/>
-                    </a:lnL>
-                    <a:lnR w="9525" cap="flat" cmpd="sng" algn="ctr">
-                      <a:solidFill>
-                        <a:srgbClr val="3A3D46"/>
-                      </a:solidFill>
-                      <a:prstDash val="solid"/>
-                      <a:round/>
-                      <a:headEnd type="none" w="med" len="med"/>
-                      <a:tailEnd type="none" w="med" len="med"/>
-                    </a:lnR>
-                    <a:lnT w="9525" cap="flat" cmpd="sng" algn="ctr">
-                      <a:solidFill>
-                        <a:srgbClr val="3A3D46"/>
-                      </a:solidFill>
-                      <a:prstDash val="solid"/>
-                      <a:round/>
-                      <a:headEnd type="none" w="med" len="med"/>
-                      <a:tailEnd type="none" w="med" len="med"/>
-                    </a:lnT>
-                    <a:lnB w="9525" cap="flat" cmpd="sng" algn="ctr">
-                      <a:solidFill>
-                        <a:srgbClr val="3A3D46"/>
-                      </a:solidFill>
-                      <a:prstDash val="solid"/>
-                      <a:round/>
-                      <a:headEnd type="none" w="med" len="med"/>
-                      <a:tailEnd type="none" w="med" len="med"/>
-                    </a:lnB>
-                  </a:tcPr>
-                </a:tc>
-                <a:tc>
-                  <a:txBody>
-                    <a:bodyPr/>
-                    <a:lstStyle/>
-                    <a:p>
-                      <a:pPr indent="0" marL="0">
-                        <a:buNone/>
-                      </a:pPr>
-                      <a:r>
-                        <a:rPr lang="en-US" sz="1700" dirty="0">
-                          <a:solidFill>
-                            <a:srgbClr val="AEB2BC"/>
-                          </a:solidFill>
-                        </a:rPr>
-                        <a:t>Kolom zona waktu di stations, untuk stasiun di WITA atau WIT</a:t>
-                      </a:r>
-                      <a:endParaRPr lang="en-US" sz="1700" dirty="0"/>
-                    </a:p>
-                  </a:txBody>
-                  <a:tcPr marL="164592" marR="164592" marT="182880" marB="182880" anchor="t">
-                    <a:lnL w="9525" cap="flat" cmpd="sng" algn="ctr">
-                      <a:solidFill>
-                        <a:srgbClr val="3A3D46"/>
-                      </a:solidFill>
-                      <a:prstDash val="solid"/>
-                      <a:round/>
-                      <a:headEnd type="none" w="med" len="med"/>
-                      <a:tailEnd type="none" w="med" len="med"/>
-                    </a:lnL>
-                    <a:lnR w="9525" cap="flat" cmpd="sng" algn="ctr">
-                      <a:solidFill>
-                        <a:srgbClr val="3A3D46"/>
-                      </a:solidFill>
-                      <a:prstDash val="solid"/>
-                      <a:round/>
-                      <a:headEnd type="none" w="med" len="med"/>
-                      <a:tailEnd type="none" w="med" len="med"/>
-                    </a:lnR>
-                    <a:lnT w="9525" cap="flat" cmpd="sng" algn="ctr">
-                      <a:solidFill>
-                        <a:srgbClr val="3A3D46"/>
-                      </a:solidFill>
-                      <a:prstDash val="solid"/>
-                      <a:round/>
-                      <a:headEnd type="none" w="med" len="med"/>
-                      <a:tailEnd type="none" w="med" len="med"/>
-                    </a:lnT>
-                    <a:lnB w="9525" cap="flat" cmpd="sng" algn="ctr">
-                      <a:solidFill>
-                        <a:srgbClr val="3A3D46"/>
-                      </a:solidFill>
-                      <a:prstDash val="solid"/>
-                      <a:round/>
-                      <a:headEnd type="none" w="med" len="med"/>
-                      <a:tailEnd type="none" w="med" len="med"/>
-                    </a:lnB>
-                  </a:tcPr>
-                </a:tc>
-              </a:tr>
-              <a:tr h="0">
-                <a:tc>
-                  <a:txBody>
-                    <a:bodyPr/>
-                    <a:lstStyle/>
-                    <a:p>
-                      <a:pPr indent="0" marL="0">
-                        <a:buNone/>
-                      </a:pPr>
-                      <a:r>
-                        <a:rPr lang="en-US" sz="1700" b="1" dirty="0">
-                          <a:solidFill>
-                            <a:srgbClr val="FFFFFF"/>
-                          </a:solidFill>
-                        </a:rPr>
-                        <a:t>Belum ada jadwal khusus</a:t>
-                      </a:r>
-                      <a:endParaRPr lang="en-US" sz="1700" dirty="0"/>
-                    </a:p>
-                  </a:txBody>
-                  <a:tcPr marL="164592" marR="164592" marT="182880" marB="182880" anchor="t">
-                    <a:lnL w="9525" cap="flat" cmpd="sng" algn="ctr">
-                      <a:solidFill>
-                        <a:srgbClr val="3A3D46"/>
-                      </a:solidFill>
-                      <a:prstDash val="solid"/>
-                      <a:round/>
-                      <a:headEnd type="none" w="med" len="med"/>
-                      <a:tailEnd type="none" w="med" len="med"/>
-                    </a:lnL>
-                    <a:lnR w="9525" cap="flat" cmpd="sng" algn="ctr">
-                      <a:solidFill>
-                        <a:srgbClr val="3A3D46"/>
-                      </a:solidFill>
-                      <a:prstDash val="solid"/>
-                      <a:round/>
-                      <a:headEnd type="none" w="med" len="med"/>
-                      <a:tailEnd type="none" w="med" len="med"/>
-                    </a:lnR>
-                    <a:lnT w="9525" cap="flat" cmpd="sng" algn="ctr">
-                      <a:solidFill>
-                        <a:srgbClr val="3A3D46"/>
-                      </a:solidFill>
-                      <a:prstDash val="solid"/>
-                      <a:round/>
-                      <a:headEnd type="none" w="med" len="med"/>
-                      <a:tailEnd type="none" w="med" len="med"/>
-                    </a:lnT>
-                    <a:lnB w="9525" cap="flat" cmpd="sng" algn="ctr">
-                      <a:solidFill>
-                        <a:srgbClr val="3A3D46"/>
-                      </a:solidFill>
-                      <a:prstDash val="solid"/>
-                      <a:round/>
-                      <a:headEnd type="none" w="med" len="med"/>
-                      <a:tailEnd type="none" w="med" len="med"/>
-                    </a:lnB>
-                  </a:tcPr>
-                </a:tc>
-                <a:tc>
-                  <a:txBody>
-                    <a:bodyPr/>
-                    <a:lstStyle/>
-                    <a:p>
-                      <a:pPr indent="0" marL="0">
-                        <a:buNone/>
-                      </a:pPr>
-                      <a:r>
-                        <a:rPr lang="en-US" sz="1700" dirty="0">
-                          <a:solidFill>
-                            <a:srgbClr val="AEB2BC"/>
-                          </a:solidFill>
-                        </a:rPr>
-                        <a:t>Tabel pengganti per tanggal (libur, siaran khusus) di atas pola mingguan</a:t>
-                      </a:r>
-                      <a:endParaRPr lang="en-US" sz="1700" dirty="0"/>
-                    </a:p>
-                  </a:txBody>
-                  <a:tcPr marL="164592" marR="164592" marT="182880" marB="182880" anchor="t">
-                    <a:lnL w="9525" cap="flat" cmpd="sng" algn="ctr">
-                      <a:solidFill>
-                        <a:srgbClr val="3A3D46"/>
-                      </a:solidFill>
-                      <a:prstDash val="solid"/>
-                      <a:round/>
-                      <a:headEnd type="none" w="med" len="med"/>
-                      <a:tailEnd type="none" w="med" len="med"/>
-                    </a:lnL>
-                    <a:lnR w="9525" cap="flat" cmpd="sng" algn="ctr">
-                      <a:solidFill>
-                        <a:srgbClr val="3A3D46"/>
-                      </a:solidFill>
-                      <a:prstDash val="solid"/>
-                      <a:round/>
-                      <a:headEnd type="none" w="med" len="med"/>
-                      <a:tailEnd type="none" w="med" len="med"/>
-                    </a:lnR>
-                    <a:lnT w="9525" cap="flat" cmpd="sng" algn="ctr">
-                      <a:solidFill>
-                        <a:srgbClr val="3A3D46"/>
-                      </a:solidFill>
-                      <a:prstDash val="solid"/>
-                      <a:round/>
-                      <a:headEnd type="none" w="med" len="med"/>
-                      <a:tailEnd type="none" w="med" len="med"/>
-                    </a:lnT>
-                    <a:lnB w="9525" cap="flat" cmpd="sng" algn="ctr">
-                      <a:solidFill>
-                        <a:srgbClr val="3A3D46"/>
-                      </a:solidFill>
-                      <a:prstDash val="solid"/>
-                      <a:round/>
-                      <a:headEnd type="none" w="med" len="med"/>
-                      <a:tailEnd type="none" w="med" len="med"/>
-                    </a:lnB>
-                  </a:tcPr>
-                </a:tc>
-              </a:tr>
-              <a:tr h="0">
-                <a:tc>
-                  <a:txBody>
-                    <a:bodyPr/>
-                    <a:lstStyle/>
-                    <a:p>
-                      <a:pPr indent="0" marL="0">
-                        <a:buNone/>
-                      </a:pPr>
-                      <a:r>
-                        <a:rPr lang="en-US" sz="1700" b="1" dirty="0">
-                          <a:solidFill>
-                            <a:srgbClr val="FFFFFF"/>
-                          </a:solidFill>
-                        </a:rPr>
-                        <a:t>Status stream diisi manual</a:t>
-                      </a:r>
-                      <a:endParaRPr lang="en-US" sz="1700" dirty="0"/>
-                    </a:p>
-                  </a:txBody>
-                  <a:tcPr marL="164592" marR="164592" marT="182880" marB="182880" anchor="t">
-                    <a:lnL w="9525" cap="flat" cmpd="sng" algn="ctr">
-                      <a:solidFill>
-                        <a:srgbClr val="3A3D46"/>
-                      </a:solidFill>
-                      <a:prstDash val="solid"/>
-                      <a:round/>
-                      <a:headEnd type="none" w="med" len="med"/>
-                      <a:tailEnd type="none" w="med" len="med"/>
-                    </a:lnL>
-                    <a:lnR w="9525" cap="flat" cmpd="sng" algn="ctr">
-                      <a:solidFill>
-                        <a:srgbClr val="3A3D46"/>
-                      </a:solidFill>
-                      <a:prstDash val="solid"/>
-                      <a:round/>
-                      <a:headEnd type="none" w="med" len="med"/>
-                      <a:tailEnd type="none" w="med" len="med"/>
-                    </a:lnR>
-                    <a:lnT w="9525" cap="flat" cmpd="sng" algn="ctr">
-                      <a:solidFill>
-                        <a:srgbClr val="3A3D46"/>
-                      </a:solidFill>
-                      <a:prstDash val="solid"/>
-                      <a:round/>
-                      <a:headEnd type="none" w="med" len="med"/>
-                      <a:tailEnd type="none" w="med" len="med"/>
-                    </a:lnT>
-                    <a:lnB w="9525" cap="flat" cmpd="sng" algn="ctr">
-                      <a:solidFill>
-                        <a:srgbClr val="3A3D46"/>
-                      </a:solidFill>
-                      <a:prstDash val="solid"/>
-                      <a:round/>
-                      <a:headEnd type="none" w="med" len="med"/>
-                      <a:tailEnd type="none" w="med" len="med"/>
-                    </a:lnB>
-                  </a:tcPr>
-                </a:tc>
-                <a:tc>
-                  <a:txBody>
-                    <a:bodyPr/>
-                    <a:lstStyle/>
-                    <a:p>
-                      <a:pPr indent="0" marL="0">
-                        <a:buNone/>
-                      </a:pPr>
-                      <a:r>
-                        <a:rPr lang="en-US" sz="1700" dirty="0">
-                          <a:solidFill>
-                            <a:srgbClr val="AEB2BC"/>
-                          </a:solidFill>
-                        </a:rPr>
-                        <a:t>Health check stream yang mengisi live / idle / offline</a:t>
-                      </a:r>
-                      <a:endParaRPr lang="en-US" sz="1700" dirty="0"/>
-                    </a:p>
-                  </a:txBody>
-                  <a:tcPr marL="164592" marR="164592" marT="182880" marB="182880" anchor="t">
-                    <a:lnL w="9525" cap="flat" cmpd="sng" algn="ctr">
-                      <a:solidFill>
-                        <a:srgbClr val="3A3D46"/>
-                      </a:solidFill>
-                      <a:prstDash val="solid"/>
-                      <a:round/>
-                      <a:headEnd type="none" w="med" len="med"/>
-                      <a:tailEnd type="none" w="med" len="med"/>
-                    </a:lnL>
-                    <a:lnR w="9525" cap="flat" cmpd="sng" algn="ctr">
-                      <a:solidFill>
-                        <a:srgbClr val="3A3D46"/>
-                      </a:solidFill>
-                      <a:prstDash val="solid"/>
-                      <a:round/>
-                      <a:headEnd type="none" w="med" len="med"/>
-                      <a:tailEnd type="none" w="med" len="med"/>
-                    </a:lnR>
-                    <a:lnT w="9525" cap="flat" cmpd="sng" algn="ctr">
-                      <a:solidFill>
-                        <a:srgbClr val="3A3D46"/>
-                      </a:solidFill>
-                      <a:prstDash val="solid"/>
-                      <a:round/>
-                      <a:headEnd type="none" w="med" len="med"/>
-                      <a:tailEnd type="none" w="med" len="med"/>
-                    </a:lnT>
-                    <a:lnB w="9525" cap="flat" cmpd="sng" algn="ctr">
-                      <a:solidFill>
-                        <a:srgbClr val="3A3D46"/>
-                      </a:solidFill>
-                      <a:prstDash val="solid"/>
-                      <a:round/>
-                      <a:headEnd type="none" w="med" len="med"/>
-                      <a:tailEnd type="none" w="med" len="med"/>
-                    </a:lnB>
-                  </a:tcPr>
-                </a:tc>
-              </a:tr>
-            </a:tbl>
-          </a:graphicData>
-        </a:graphic>
-      </p:graphicFrame>
-      <p:sp>
-        <p:nvSpPr>
-          <p:cNvPr id="25" name="Slide Number Placeholder 0"/>
-          <p:cNvSpPr>
-            <a:spLocks noGrp="1"/>
-          </p:cNvSpPr>
-          <p:nvPr>
-            <p:ph type="sldNum" sz="quarter" idx="4294967295"/>
-          </p:nvPr>
-        </p:nvSpPr>
-        <p:spPr>
-          <a:xfrm>
-            <a:off x="11155680" y="6355080"/>
-            <a:ext cx="457200" cy="274320"/>
-          </a:xfrm>
-          <a:prstGeom prst="rect">
-            <a:avLst/>
-          </a:prstGeom>
-          <a:extLst>
-            <a:ext uri="{C572A759-6A51-4108-AA02-DFA0A04FC94B}">
-              <ma14:wrappingTextBoxFlag xmlns:ma14="http://schemas.microsoft.com/office/mac/drawingml/2011/main" val="0"/>
-            </a:ext>
-          </a:extLst>
-        </p:spPr>
-        <p:txBody>
-          <a:bodyPr/>
-          <a:lstStyle>
-            <a:lvl1pPr>
-              <a:defRPr sz="1000">
-                <a:solidFill>
-                  <a:schemeClr val="accent5"/>
-                </a:solidFill>
-              </a:defRPr>
-            </a:lvl1pPr>
-          </a:lstStyle>
-          <a:p>
-            <a:pPr algn="r"/>
-            <a:fld id="{F7021451-1387-4CA6-816F-3879F97B5CBC}" type="slidenum">
-              <a:rPr b="0" lang="en-US"/>
-              <a:t>14</a:t>
-            </a:fld>
-            <a:endParaRPr lang="en-US"/>
-          </a:p>
-        </p:txBody>
-      </p:sp>
-    </p:spTree>
-  </p:cSld>
-  <p:clrMapOvr>
-    <a:masterClrMapping/>
-  </p:clrMapOvr>
-</p:sld>
-</file>
-
-<file path=ppt/slides/slide15.xml><?xml version="1.0" encoding="utf-8"?>
-<p:sld xmlns:a="http://schemas.openxmlformats.org/drawingml/2006/main" xmlns:r="http://schemas.openxmlformats.org/officeDocument/2006/relationships" xmlns:p="http://schemas.openxmlformats.org/presentationml/2006/main">
-  <p:cSld name="Slide 15">
-    <p:spTree>
-      <p:nvGrpSpPr>
-        <p:cNvPr id="1" name=""/>
-        <p:cNvGrpSpPr/>
-        <p:nvPr/>
-      </p:nvGrpSpPr>
-      <p:grpSpPr>
-        <a:xfrm>
-          <a:off x="0" y="0"/>
-          <a:ext cx="0" cy="0"/>
-          <a:chOff x="0" y="0"/>
-          <a:chExt cx="0" cy="0"/>
-        </a:xfrm>
-      </p:grpSpPr>
-      <p:sp>
-        <p:nvSpPr>
-          <p:cNvPr id="2" name="Text 0"/>
-          <p:cNvSpPr/>
-          <p:nvPr>
-            <p:ph idx="100" type="title" hasCustomPrompt="1"/>
-          </p:nvPr>
-        </p:nvSpPr>
-        <p:spPr>
-          <a:xfrm>
-            <a:off x="548640" y="457200"/>
-            <a:ext cx="11064240" cy="777240"/>
-          </a:xfrm>
-          <a:prstGeom prst="rect">
-            <a:avLst/>
-          </a:prstGeom>
-          <a:noFill/>
-          <a:ln/>
-        </p:spPr>
-        <p:txBody>
-          <a:bodyPr wrap="square" lIns="0" tIns="0" rIns="0" bIns="0" rtlCol="0" anchor="t"/>
-          <a:lstStyle/>
-          <a:p>
-            <a:pPr algn="l" indent="0" marL="0">
-              <a:buNone/>
-            </a:pPr>
-            <a:r>
-              <a:rPr lang="en-US" sz="3200" b="1" dirty="0">
-                <a:solidFill>
-                  <a:schemeClr val="bg1"/>
-                </a:solidFill>
-              </a:rPr>
               <a:t>Link demo, slide, dan produk asli</a:t>
             </a:r>
             <a:endParaRPr lang="en-US" sz="3200" dirty="0"/>
@@ -6411,7 +5587,7 @@
             <a:pPr algn="r"/>
             <a:fld id="{F7021451-1387-4CA6-816F-3879F97B5CBC}" type="slidenum">
               <a:rPr b="0" lang="en-US"/>
-              <a:t>15</a:t>
+              <a:t>14</a:t>
             </a:fld>
             <a:endParaRPr lang="en-US"/>
           </a:p>
@@ -9128,8 +8304,8 @@
         </p:blipFill>
         <p:spPr>
           <a:xfrm>
-            <a:off x="548640" y="1417320"/>
-            <a:ext cx="4835236" cy="4800600"/>
+            <a:off x="548640" y="1280160"/>
+            <a:ext cx="5157585" cy="5120640"/>
           </a:xfrm>
           <a:prstGeom prst="rect">
             <a:avLst/>
@@ -9144,8 +8320,8 @@
         </p:nvSpPr>
         <p:spPr>
           <a:xfrm>
-            <a:off x="5795356" y="1417320"/>
-            <a:ext cx="5817524" cy="365760"/>
+            <a:off x="6117705" y="1417320"/>
+            <a:ext cx="5495175" cy="365760"/>
           </a:xfrm>
           <a:prstGeom prst="rect">
             <a:avLst/>
@@ -9183,8 +8359,8 @@
         </p:nvSpPr>
         <p:spPr>
           <a:xfrm>
-            <a:off x="5795356" y="1801368"/>
-            <a:ext cx="5817524" cy="731520"/>
+            <a:off x="6117705" y="1801368"/>
+            <a:ext cx="5495175" cy="731520"/>
           </a:xfrm>
           <a:prstGeom prst="rect">
             <a:avLst/>
@@ -9219,8 +8395,8 @@
         </p:nvSpPr>
         <p:spPr>
           <a:xfrm>
-            <a:off x="5795356" y="2606040"/>
-            <a:ext cx="5817524" cy="365760"/>
+            <a:off x="6117705" y="2606040"/>
+            <a:ext cx="5495175" cy="365760"/>
           </a:xfrm>
           <a:prstGeom prst="rect">
             <a:avLst/>
@@ -9258,8 +8434,8 @@
         </p:nvSpPr>
         <p:spPr>
           <a:xfrm>
-            <a:off x="5795356" y="2990088"/>
-            <a:ext cx="5817524" cy="731520"/>
+            <a:off x="6117705" y="2990088"/>
+            <a:ext cx="5495175" cy="731520"/>
           </a:xfrm>
           <a:prstGeom prst="rect">
             <a:avLst/>
@@ -9294,8 +8470,8 @@
         </p:nvSpPr>
         <p:spPr>
           <a:xfrm>
-            <a:off x="5795356" y="3794760"/>
-            <a:ext cx="5817524" cy="365760"/>
+            <a:off x="6117705" y="3794760"/>
+            <a:ext cx="5495175" cy="365760"/>
           </a:xfrm>
           <a:prstGeom prst="rect">
             <a:avLst/>
@@ -9333,8 +8509,8 @@
         </p:nvSpPr>
         <p:spPr>
           <a:xfrm>
-            <a:off x="5795356" y="4178808"/>
-            <a:ext cx="5817524" cy="731520"/>
+            <a:off x="6117705" y="4178808"/>
+            <a:ext cx="5495175" cy="731520"/>
           </a:xfrm>
           <a:prstGeom prst="rect">
             <a:avLst/>
@@ -9369,8 +8545,8 @@
         </p:nvSpPr>
         <p:spPr>
           <a:xfrm>
-            <a:off x="5795356" y="4983480"/>
-            <a:ext cx="5817524" cy="365760"/>
+            <a:off x="6117705" y="4983480"/>
+            <a:ext cx="5495175" cy="365760"/>
           </a:xfrm>
           <a:prstGeom prst="rect">
             <a:avLst/>
@@ -9408,8 +8584,8 @@
         </p:nvSpPr>
         <p:spPr>
           <a:xfrm>
-            <a:off x="5795356" y="5367528"/>
-            <a:ext cx="5817524" cy="731520"/>
+            <a:off x="6117705" y="5367528"/>
+            <a:ext cx="5495175" cy="731520"/>
           </a:xfrm>
           <a:prstGeom prst="rect">
             <a:avLst/>

</xml_diff>